<commit_message>
Set project name Orphan Finder (team Past the Wall) on README and title slide
</commit_message>
<xml_diff>
--- a/demo/HitScreen_pitch.pptx
+++ b/demo/HitScreen_pitch.pptx
@@ -3972,7 +3972,7 @@
                 </a:solidFill>
                 <a:latin typeface="Arial"/>
               </a:rPr>
-              <a:t>The Analog Wall</a:t>
+              <a:t>Orphan Finder</a:t>
             </a:r>
           </a:p>
         </p:txBody>
@@ -3985,8 +3985,8 @@
         </p:nvSpPr>
         <p:spPr>
           <a:xfrm>
-            <a:off x="822960" y="3383280"/>
-            <a:ext cx="10515600" cy="1097280"/>
+            <a:off x="822960" y="3246120"/>
+            <a:ext cx="10515600" cy="1554480"/>
           </a:xfrm>
           <a:prstGeom prst="rect">
             <a:avLst/>
@@ -4001,7 +4001,19 @@
           <a:p>
             <a:pPr algn="l"/>
             <a:r>
-              <a:rPr sz="2200" b="0">
+              <a:rPr sz="2000" b="1">
+                <a:solidFill>
+                  <a:srgbClr val="58A6FF"/>
+                </a:solidFill>
+                <a:latin typeface="Arial"/>
+              </a:rPr>
+              <a:t>Team: Past the Wall</a:t>
+            </a:r>
+          </a:p>
+          <a:p>
+            <a:pPr algn="l"/>
+            <a:r>
+              <a:rPr sz="2000">
                 <a:solidFill>
                   <a:srgbClr val="9198A1"/>
                 </a:solidFill>

</xml_diff>

<commit_message>
Rewrite pitch: expert voice, concrete results, Claude Science named, honesty as one earned line
</commit_message>
<xml_diff>
--- a/demo/HitScreen_pitch.pptx
+++ b/demo/HitScreen_pitch.pptx
@@ -508,7 +508,7 @@
           <a:lstStyle/>
           <a:p>
             <a:r>
-              <a:t>Hi. I'm James Martin. Most drug discovery finds new targets by chemical similarity. You take a molecule, find something like it, and borrow its target. But that approach fails, quietly, exactly where new medicines have to come from.</a:t>
+              <a:t>I'm James Martin. This is Orphan Finder. Half of all approved drugs trace back to natural products. But most natural products have no known target, so they sit on the shelf. Orphan Finder predicts those targets, and tells you which predictions to believe.</a:t>
             </a:r>
           </a:p>
         </p:txBody>
@@ -578,7 +578,7 @@
           <a:lstStyle/>
           <a:p>
             <a:r>
-              <a:t>We measured where it fails. We call it the analog wall. We looked at six hundred and ninety-five thousand natural products. Sixty-three percent have no close match among known drugs. For those, similarity prediction simply cannot work. There is nothing to compare to. Nobody usually measures this line. We did.</a:t>
+              <a:t>Target prediction leans on chemical similarity. Find a molecule like a known drug, inherit its target. That breaks the moment a molecule has no close relative. We quantified exactly where it breaks. Across 695,000 natural products in COCONUT, similarity prediction collapses at a Tanimoto of 0.5. Sixty-three percent of natural product space sits past that wall, unreachable. So every prediction carries a distance to that wall. Above it, trust the analogy. Below it, we dock the pose against real controls.</a:t>
             </a:r>
           </a:p>
         </p:txBody>
@@ -648,7 +648,7 @@
           <a:lstStyle/>
           <a:p>
             <a:r>
-              <a:t>So we built an open pipeline that respects that wall. It nominates a target, and it tells you how much to trust the nomination. For the risky predictions, it checks them with real docking and real controls. Claude ran the whole thing. And here is the part I like most. Claude audited its own work, and caught real mistakes as they happened. One receptor was labeled human but was actually a rabbit protein. Claude caught it. One docking test let caffeine beat the real drug. Claude flagged it and fixed it.</a:t>
+              <a:t>The whole engine runs on Claude Science. It pulled the data from COCONUT, ChEMBL, and the Broad repurposing library, ran ESM-2 protein embeddings, and dispatched docking to GPUs on Modal. One prompt drives a pipeline that fingerprints 695,000 compounds and docks the survivors against verified receptor structures. A scientist points it at a molecule, and it returns ranked, structure-checked targets.</a:t>
             </a:r>
           </a:p>
         </p:txBody>
@@ -718,7 +718,7 @@
           <a:lstStyle/>
           <a:p>
             <a:r>
-              <a:t>Here is what that honesty buys you. A natural product with no known target. And an approved drug. Two unrelated molecules. They land on the same tuberculosis target, through one shared test. Both beat a decoy control. An independent structure tool confirms how they bind. That is a real, checkable result. Not a lucky guess.</a:t>
+              <a:t>Here is what it finds. A natural product with no annotated target, and an approved drug, share no chemical scaffold. Both land on the same enzyme: InhA, the tuberculosis target of isoniazid. Both dock into the substrate channel. Both contact the catalytic tyrosine, Tyr158. Both beat a matched decoy set. Docking alone can flatter a pose, so we confirmed it a second way, with an independent structure predictor. It agrees. Two unrelated molecules, one validated target, reached by one standard.</a:t>
             </a:r>
           </a:p>
         </p:txBody>
@@ -788,7 +788,7 @@
           <a:lstStyle/>
           <a:p>
             <a:r>
-              <a:t>Then we asked the question that matters for antibiotics. Will the target still work after the bacteria mutate? Normal docking is blind to that. So we built a resistance layer. It passes the mutation test that ordinary docking fails. It finds natural products that hold up better against resistance than the current drug. Seven of them, on one enzyme family alone.</a:t>
+              <a:t>Then the question that decides an antibiotic's future: does the target survive resistance mutations? We built a mutant-aware scoring layer and validated it on known resistance: it reproduces how trimethoprim loses DHFR, and pyrimethamine loses malarial DHFR. Then we screened orphan natural products against those same mutated pockets. On DHFR, seven natural products are predicted to hold their binding where the front-line drug fails. Those are resistance-robust leads, ranked and ready to test.</a:t>
             </a:r>
           </a:p>
         </p:txBody>
@@ -858,7 +858,7 @@
           <a:lstStyle/>
           <a:p>
             <a:r>
-              <a:t>This is not a one-target trick. We pointed the same pipeline at Alzheimer's targets, across one point seven million compounds. And at gut microbe molecules, where a whole family of pigments converges on one human receptor. Same tool. Three different problems.</a:t>
+              <a:t>The same engine generalizes. It screened 1.7 million compounds for Alzheimer's targets, and flagged a family of microbial carotenoids all converging on the human receptor PXR, every one confirmed by docking. Antibiotics, neurodegeneration, the microbiome. One pipeline.</a:t>
             </a:r>
           </a:p>
         </p:txBody>
@@ -928,7 +928,7 @@
           <a:lstStyle/>
           <a:p>
             <a:r>
-              <a:t>One last thing, and it matters. Every molecule here is a lead to test in a lab. Never a finished drug. When the pipeline cannot support a hit, it says so. We report those too. It is fully open. Everything you just saw reproduces from the repository. Built with Claude. Thank you.</a:t>
+              <a:t>Orphan Finder turns the ninety percent of natural products with no known target into ranked, structure-backed, resistance-aware leads. It is fully open. Every result reproduces from the repository. Built on Claude Science. Thank you.</a:t>
             </a:r>
           </a:p>
         </p:txBody>
@@ -4408,7 +4408,7 @@
                 </a:solidFill>
                 <a:latin typeface="Arial"/>
               </a:rPr>
-              <a:t>WHAT WE BUILT  ·  ORCHESTRATED WITH CLAUDE</a:t>
+              <a:t>BUILT ON CLAUDE SCIENCE</a:t>
             </a:r>
           </a:p>
         </p:txBody>
@@ -4443,7 +4443,7 @@
                 </a:solidFill>
                 <a:latin typeface="Arial"/>
               </a:rPr>
-              <a:t>A pipeline that respects the wall, and audits itself</a:t>
+              <a:t>One prompt drives the whole engine</a:t>
             </a:r>
           </a:p>
         </p:txBody>
@@ -4522,7 +4522,7 @@
                 </a:solidFill>
                 <a:latin typeface="Arial"/>
               </a:rPr>
-              <a:t>Nominate with confidence</a:t>
+              <a:t>Orchestrate</a:t>
             </a:r>
           </a:p>
         </p:txBody>
@@ -4557,7 +4557,7 @@
                 </a:solidFill>
                 <a:latin typeface="Arial"/>
               </a:rPr>
-              <a:t>Every prediction carries a distance to the analog wall, so you know how much to trust it.</a:t>
+              <a:t>Pulls COCONUT, ChEMBL, and the Broad repurposing library into one screening set.</a:t>
             </a:r>
           </a:p>
         </p:txBody>
@@ -4636,7 +4636,7 @@
                 </a:solidFill>
                 <a:latin typeface="Arial"/>
               </a:rPr>
-              <a:t>Validate the risky ones</a:t>
+              <a:t>Model + dock</a:t>
             </a:r>
           </a:p>
         </p:txBody>
@@ -4671,7 +4671,7 @@
                 </a:solidFill>
                 <a:latin typeface="Arial"/>
               </a:rPr>
-              <a:t>Below-wall nominations are checked by docking against real positive and negative controls.</a:t>
+              <a:t>Runs ESM-2 embeddings and dispatches docking to GPUs on Modal, scoring every pose.</a:t>
             </a:r>
           </a:p>
         </p:txBody>
@@ -4746,11 +4746,11 @@
             <a:r>
               <a:rPr sz="1900" b="1">
                 <a:solidFill>
-                  <a:srgbClr val="3FB950"/>
+                  <a:srgbClr val="58A6FF"/>
                 </a:solidFill>
                 <a:latin typeface="Arial"/>
               </a:rPr>
-              <a:t>Claude caught real errors, live</a:t>
+              <a:t>Return ranked leads</a:t>
             </a:r>
           </a:p>
         </p:txBody>
@@ -4785,7 +4785,7 @@
                 </a:solidFill>
                 <a:latin typeface="Arial"/>
               </a:rPr>
-              <a:t>A receptor mislabeled as human was actually a rabbit ortholog. A docking box let caffeine beat the real drug. Claude flagged and fixed both.</a:t>
+              <a:t>Fingerprints 695,000 compounds and returns structure-checked target hypotheses.</a:t>
             </a:r>
           </a:p>
         </p:txBody>
@@ -5690,7 +5690,7 @@
                 </a:solidFill>
                 <a:latin typeface="Arial"/>
               </a:rPr>
-              <a:t>Every molecule is a lead to test. Never a finished drug.</a:t>
+              <a:t>90% of natural products have no known target. We rank them.</a:t>
             </a:r>
           </a:p>
         </p:txBody>
@@ -5725,31 +5725,8 @@
                 </a:solidFill>
                 <a:latin typeface="Arial"/>
               </a:rPr>
-              <a:t>When the pipeline cannot support a hit, it says so, and we report those too.</a:t>
-            </a:r>
-          </a:p>
-          <a:p>
-            <a:pPr algn="l"/>
-            <a:r>
-              <a:rPr sz="2000" b="0">
-                <a:solidFill>
-                  <a:srgbClr val="9198A1"/>
-                </a:solidFill>
-                <a:latin typeface="Arial"/>
-              </a:rPr>
-              <a:t/>
-            </a:r>
-          </a:p>
-          <a:p>
-            <a:pPr algn="l"/>
-            <a:r>
-              <a:rPr sz="2000" b="0">
-                <a:solidFill>
-                  <a:srgbClr val="9198A1"/>
-                </a:solidFill>
-                <a:latin typeface="Arial"/>
-              </a:rPr>
-              <a:t>Fully open. Everything you just saw reproduces from the repository.</a:t>
+              <a:t>Structure-backed, resistance-aware leads, ready to test.
+Fully open. Every result reproduces from the repository.</a:t>
             </a:r>
           </a:p>
         </p:txBody>
@@ -5819,7 +5796,7 @@
                 </a:solidFill>
                 <a:latin typeface="Arial"/>
               </a:rPr>
-              <a:t>Built with Claude</a:t>
+              <a:t>Built on Claude Science</a:t>
             </a:r>
           </a:p>
         </p:txBody>

</xml_diff>

<commit_message>
Rewrite pitch as one cohesive story: jargon explained, Tanimoto 0.28 defended, microbiome result stated
</commit_message>
<xml_diff>
--- a/demo/HitScreen_pitch.pptx
+++ b/demo/HitScreen_pitch.pptx
@@ -508,7 +508,7 @@
           <a:lstStyle/>
           <a:p>
             <a:r>
-              <a:t>I'm James Martin. This is Orphan Finder. Half of all approved drugs trace back to natural products. But most natural products have no known target, so they sit on the shelf. Orphan Finder predicts those targets, and tells you which predictions to believe.</a:t>
+              <a:t>I'm James Martin, and this is Orphan Finder. Nature is still our best source of medicine. About half of all approved drugs come from natural products, from plants, microbes, and fungi. But for most of these molecules, we don't know what they hit in the body. We can see they're active. We just don't know where they act. We call those orphan molecules. Orphan Finder gives them a target.</a:t>
             </a:r>
           </a:p>
         </p:txBody>
@@ -578,7 +578,7 @@
           <a:lstStyle/>
           <a:p>
             <a:r>
-              <a:t>Target prediction leans on chemical similarity. Find a molecule like a known drug, inherit its target. That breaks the moment a molecule has no close relative. We quantified exactly where it breaks. Across 695,000 natural products in COCONUT, similarity prediction collapses at a Tanimoto of 0.5. Sixty-three percent of natural product space sits past that wall, unreachable. So every prediction carries a distance to that wall. Above it, trust the analogy. Below it, we dock the pose against real controls.</a:t>
+              <a:t>Why don't we already know? Because of how target prediction normally works. The usual approach is guilt by association. If a new molecule looks like a known drug, we assume it hits the same protein. Chemists score that resemblance from zero to one: one means chemical twins, zero means nothing in common. That works right up until a molecule looks like nothing we've seen. And orphans, by definition, look like nothing we've seen. We measured where it breaks. Below one half, prediction falls apart. Across 695,000 natural products, sixty-three percent live past that line. We call it the analog wall. Orphan Finder always knows which side of the wall it's on. With a look-alike, it uses it. Without one, it stops guessing and turns to physics, folding the molecule into the protein to see if it truly fits.</a:t>
             </a:r>
           </a:p>
         </p:txBody>
@@ -648,7 +648,7 @@
           <a:lstStyle/>
           <a:p>
             <a:r>
-              <a:t>The whole engine runs on Claude Science. It pulled the data from COCONUT, ChEMBL, and the Broad repurposing library, ran ESM-2 protein embeddings, and dispatched docking to GPUs on Modal. One prompt drives a pipeline that fingerprints 695,000 compounds and docks the survivors against verified receptor structures. A scientist points it at a molecule, and it returns ranked, structure-checked targets.</a:t>
+              <a:t>That system runs on Claude Science. From one instruction, it gathers the world's natural-product libraries, reads each protein's structure, sends the hard cases to physics-based docking on GPUs, and ranks what it finds. You point it at a molecule. It hands back the likely targets, and how much to trust each one.</a:t>
             </a:r>
           </a:p>
         </p:txBody>
@@ -718,7 +718,7 @@
           <a:lstStyle/>
           <a:p>
             <a:r>
-              <a:t>Here is what it finds. A natural product with no annotated target, and an approved drug, share no chemical scaffold. Both land on the same enzyme: InhA, the tuberculosis target of isoniazid. Both dock into the substrate channel. Both contact the catalytic tyrosine, Tyr158. Both beat a matched decoy set. Docking alone can flatter a pose, so we confirmed it a second way, with an independent structure predictor. It agrees. Two unrelated molecules, one validated target, reached by one standard.</a:t>
+              <a:t>So does the physics route really find targets past the wall? Here's the test that convinced me. Two molecules: one orphan natural product, one approved drug. On that similarity score they sit at zero point two eight. They're chemical strangers, no shared skeleton. Yet both fold into the same pocket of the same enzyme, InhA, the protein the tuberculosis drug isoniazid attacks. Both grip its catalytic residue. Both beat a field of decoys, and a separate structure method agrees. Two strangers, the same target, found by one rule. That's the tool working.</a:t>
             </a:r>
           </a:p>
         </p:txBody>
@@ -788,7 +788,7 @@
           <a:lstStyle/>
           <a:p>
             <a:r>
-              <a:t>Then the question that decides an antibiotic's future: does the target survive resistance mutations? We built a mutant-aware scoring layer and validated it on known resistance: it reproduces how trimethoprim loses DHFR, and pyrimethamine loses malarial DHFR. Then we screened orphan natural products against those same mutated pockets. On DHFR, seven natural products are predicted to hold their binding where the front-line drug fails. Those are resistance-robust leads, ranked and ready to test.</a:t>
+              <a:t>For an antibiotic, naming the target isn't enough. Bacteria fight back. They mutate the target until the drug stops sticking. That's resistance, and it's killing our medicines faster than we replace them. So we taught Orphan Finder a harder question: not just does it bind, but does it still bind after the bacteria mutate? We checked it against resistance we already understand, and it correctly predicted how today's drugs fail. Then we turned it on the orphans. Against the enzyme DHFR, seven natural products are predicted to keep working right where the frontline drug is defeated. Resistance-proof leads, from molecules nobody had a target for.</a:t>
             </a:r>
           </a:p>
         </p:txBody>
@@ -858,7 +858,7 @@
           <a:lstStyle/>
           <a:p>
             <a:r>
-              <a:t>The same engine generalizes. It screened 1.7 million compounds for Alzheimer's targets, and flagged a family of microbial carotenoids all converging on the human receptor PXR, every one confirmed by docking. Antibiotics, neurodegeneration, the microbiome. One pipeline.</a:t>
+              <a:t>And this isn't just tuberculosis. We pointed the same engine at gut-microbe molecules and asked what they do to us. It flagged a whole family of microbial pigments all hitting one human receptor, PXR, the switch that controls how our bodies clear drugs. Every one confirmed by docking. Antibiotics, the microbiome, the brain. One engine.</a:t>
             </a:r>
           </a:p>
         </p:txBody>
@@ -928,7 +928,7 @@
           <a:lstStyle/>
           <a:p>
             <a:r>
-              <a:t>Orphan Finder turns the ninety percent of natural products with no known target into ranked, structure-backed, resistance-aware leads. It is fully open. Every result reproduces from the repository. Built on Claude Science. Thank you.</a:t>
+              <a:t>Ninety percent of nature's molecules have no known target. That's not a dead end, it's an unopened library. Orphan Finder opens it, and hands you ranked, structure-backed, resistance-aware leads to test. Fully open, fully reproducible. Built on Claude Science. Thank you.</a:t>
             </a:r>
           </a:p>
         </p:txBody>

</xml_diff>

<commit_message>
Fix convergence-pair wording (repurposing compound, not approved drug), explain CNS arm on slide 6, add project description
</commit_message>
<xml_diff>
--- a/demo/HitScreen_pitch.pptx
+++ b/demo/HitScreen_pitch.pptx
@@ -718,7 +718,7 @@
           <a:lstStyle/>
           <a:p>
             <a:r>
-              <a:t>So does the physics route really find targets past the wall? Here's the test that convinced me. Two molecules: one orphan natural product, one approved drug. On that similarity score they sit at zero point two eight. They're chemical strangers, no shared skeleton. Yet both fold into the same pocket of the same enzyme, InhA, the protein the tuberculosis drug isoniazid attacks. Both grip its catalytic residue. Both beat a field of decoys, and a separate structure method agrees. Two strangers, the same target, found by one rule. That's the tool working.</a:t>
+              <a:t>So does the physics route really find targets past the wall? Here's the test that convinced me. Two molecules: one orphan natural product, and a compound from a drug-repurposing library, something already made for a different job. On that similarity score they sit at zero point two eight. They're chemical strangers, no shared skeleton. Yet both fold into the same pocket of the same enzyme, InhA. That's the enzyme the frontline tuberculosis drug isoniazid was built to shut down. Both of our molecules grip its catalytic residue. Both beat a field of decoys, and a separate structure method agrees. Two strangers, the same target, found by one rule. That's the tool working.</a:t>
             </a:r>
           </a:p>
         </p:txBody>
@@ -4875,13 +4875,13 @@
           <a:p>
             <a:pPr algn="l"/>
             <a:r>
-              <a:rPr sz="2800" b="1">
+              <a:rPr sz="2600" b="1">
                 <a:solidFill>
                   <a:srgbClr val="E6EDF3"/>
                 </a:solidFill>
                 <a:latin typeface="Arial"/>
               </a:rPr>
-              <a:t>An orphan natural product and an approved drug converge on the same TB target</a:t>
+              <a:t>An orphan natural product and a repurposing-library compound converge on the same TB target</a:t>
             </a:r>
           </a:p>
         </p:txBody>
@@ -4910,37 +4910,14 @@
           <a:p>
             <a:pPr algn="l"/>
             <a:r>
-              <a:rPr sz="1800" b="0">
+              <a:rPr sz="1700" b="0">
                 <a:solidFill>
-                  <a:srgbClr val="E6EDF3"/>
+                  <a:srgbClr val="9198A1"/>
                 </a:solidFill>
                 <a:latin typeface="Arial"/>
               </a:rPr>
-              <a:t>Two chemically unrelated molecules land on M. tuberculosis InhA through one shared validation standard.</a:t>
-            </a:r>
-          </a:p>
-          <a:p>
-            <a:pPr algn="l"/>
-            <a:r>
-              <a:rPr sz="1800" b="0">
-                <a:solidFill>
-                  <a:srgbClr val="E6EDF3"/>
-                </a:solidFill>
-                <a:latin typeface="Arial"/>
-              </a:rPr>
-              <a:t/>
-            </a:r>
-          </a:p>
-          <a:p>
-            <a:pPr algn="l"/>
-            <a:r>
-              <a:rPr sz="1800" b="0">
-                <a:solidFill>
-                  <a:srgbClr val="E6EDF3"/>
-                </a:solidFill>
-                <a:latin typeface="Arial"/>
-              </a:rPr>
-              <a:t>Both beat a property-matched decoy control. An independent structure predictor confirms the poses.</a:t>
+              <a:t>Two molecules that share no chemical skeleton (Tanimoto 0.28) both land on M. tuberculosis InhA through one shared validation standard.
+Both grip the catalytic Tyr158, both beat a matched decoy set, and an independent structure predictor confirms the poses.</a:t>
             </a:r>
           </a:p>
         </p:txBody>
@@ -5228,7 +5205,7 @@
                 </a:solidFill>
                 <a:latin typeface="Arial"/>
               </a:rPr>
-              <a:t>SAME INSTRUMENT, THREE PROBLEMS</a:t>
+              <a:t>ONE ENGINE, MANY DISEASES</a:t>
             </a:r>
           </a:p>
         </p:txBody>
@@ -5257,13 +5234,13 @@
           <a:p>
             <a:pPr algn="l"/>
             <a:r>
-              <a:rPr sz="3000" b="1">
+              <a:rPr sz="2800" b="1">
                 <a:solidFill>
                   <a:srgbClr val="E6EDF3"/>
                 </a:solidFill>
                 <a:latin typeface="Arial"/>
               </a:rPr>
-              <a:t>It is not a one-target trick</a:t>
+              <a:t>The same tool, pointed at very different problems</a:t>
             </a:r>
           </a:p>
         </p:txBody>
@@ -5342,7 +5319,7 @@
                 </a:solidFill>
                 <a:latin typeface="Arial"/>
               </a:rPr>
-              <a:t>Antimicrobials</a:t>
+              <a:t>Antibiotic resistance</a:t>
             </a:r>
           </a:p>
         </p:txBody>
@@ -5377,7 +5354,7 @@
                 </a:solidFill>
                 <a:latin typeface="Arial"/>
               </a:rPr>
-              <a:t>Natural-product and repurposing leads against priority pathogens, resistance-aware.</a:t>
+              <a:t>Orphan natural products nominated as resistance-robust leads against priority pathogens.</a:t>
             </a:r>
           </a:p>
         </p:txBody>
@@ -5456,7 +5433,7 @@
                 </a:solidFill>
                 <a:latin typeface="Arial"/>
               </a:rPr>
-              <a:t>Alzheimer's / CNS</a:t>
+              <a:t>The microbiome</a:t>
             </a:r>
           </a:p>
         </p:txBody>
@@ -5491,7 +5468,7 @@
                 </a:solidFill>
                 <a:latin typeface="Arial"/>
               </a:rPr>
-              <a:t>Same pipeline, ported unchanged across 1.7M CNS-like compounds.</a:t>
+              <a:t>A family of gut-microbe pigments all converge on PXR, the human receptor that controls how we clear drugs. Confirmed by docking.</a:t>
             </a:r>
           </a:p>
         </p:txBody>
@@ -5570,7 +5547,7 @@
                 </a:solidFill>
                 <a:latin typeface="Arial"/>
               </a:rPr>
-              <a:t>Microbiome to host</a:t>
+              <a:t>The brain: Alzheimer's</a:t>
             </a:r>
           </a:p>
         </p:txBody>
@@ -5605,7 +5582,7 @@
                 </a:solidFill>
                 <a:latin typeface="Arial"/>
               </a:rPr>
-              <a:t>A family of microbial carotenoids converges on the human receptor PXR, confirmed by docking.</a:t>
+              <a:t>Same engine run across 1.7M brain-penetrant molecules against the enzymes behind Alzheimer's, AChE and MAO-B. Scales and transfers cleanly.</a:t>
             </a:r>
           </a:p>
         </p:txBody>

</xml_diff>

<commit_message>
Comprehensive uncapped script; deck speaker notes synced verbatim per slide
</commit_message>
<xml_diff>
--- a/demo/HitScreen_pitch.pptx
+++ b/demo/HitScreen_pitch.pptx
@@ -508,7 +508,7 @@
           <a:lstStyle/>
           <a:p>
             <a:r>
-              <a:t>I'm James Martin, and this is Orphan Finder. Nature is still our best source of medicine. About half of all approved drugs come from natural products, from plants, microbes, and fungi. But for most of these molecules, we don't know what they hit in the body. We can see they're active. We just don't know where they act. We call those orphan molecules. Orphan Finder gives them a target.</a:t>
+              <a:t>I'm James Martin, and this is Orphan Finder. Nature is still our best source of medicine. About half of all approved drugs trace back to a natural product, to something first made by a plant, a microbe, or a fungus. But most of these molecules are stuck. We can see they do something, but we don't know which protein in the body they act on. And without the target, you can't develop the drug. We call those orphan molecules. Orphan Finder gives them a target.</a:t>
             </a:r>
           </a:p>
         </p:txBody>
@@ -578,7 +578,7 @@
           <a:lstStyle/>
           <a:p>
             <a:r>
-              <a:t>Why don't we already know? Because of how target prediction normally works. The usual approach is guilt by association. If a new molecule looks like a known drug, we assume it hits the same protein. Chemists score that resemblance from zero to one: one means chemical twins, zero means nothing in common. That works right up until a molecule looks like nothing we've seen. And orphans, by definition, look like nothing we've seen. We measured where it breaks. Below one half, prediction falls apart. Across 695,000 natural products, sixty-three percent live past that line. We call it the analog wall. Orphan Finder always knows which side of the wall it's on. With a look-alike, it uses it. Without one, it stops guessing and turns to physics, folding the molecule into the protein to see if it truly fits.</a:t>
+              <a:t>Why don't we already know their targets? It comes down to how prediction normally works. The standard approach is guilt by association: if a new molecule looks like a drug we understand, we assume it hits the same protein. Chemists score that resemblance from zero to one. One means near-identical twins; zero means nothing in common. That works, but only up to a point. The moment a molecule looks like nothing we've seen, there's nothing to compare it to, and the method quietly falls apart. And orphans, by definition, are the molecules that look like nothing we've seen. So we measured where it breaks, and found a hard cliff: below a similarity of one half, prediction stops working. Across 695,000 natural products, sixty-three percent live past that cliff. We call it the analog wall. Our central idea: Orphan Finder always knows which side of that wall it's on. With a close relative, it uses the shortcut. Past the wall, it stops guessing from resemblance and switches to physics, folding the molecule's 3D shape into the protein's pocket to see if it truly fits.</a:t>
             </a:r>
           </a:p>
         </p:txBody>
@@ -648,7 +648,7 @@
           <a:lstStyle/>
           <a:p>
             <a:r>
-              <a:t>That system runs on Claude Science. From one instruction, it gathers the world's natural-product libraries, reads each protein's structure, sends the hard cases to physics-based docking on GPUs, and ranks what it finds. You point it at a molecule. It hands back the likely targets, and how much to trust each one.</a:t>
+              <a:t>That whole system runs on Claude Science. From one instruction, it pulls together the world's natural-product libraries, reads in each protein's 3D structure, sends the hard past-the-wall cases to physics-based docking on GPUs, and ranks everything by how strong and how trustworthy the prediction is. You point it at a molecule, and it hands back the proteins it most likely targets, with an honest confidence for each. A months-long lab hunt becomes a single run.</a:t>
             </a:r>
           </a:p>
         </p:txBody>
@@ -718,7 +718,7 @@
           <a:lstStyle/>
           <a:p>
             <a:r>
-              <a:t>So does the physics route really find targets past the wall? Here's the test that convinced me. Two molecules: one orphan natural product, and a compound from a drug-repurposing library, something already made for a different job. On that similarity score they sit at zero point two eight. They're chemical strangers, no shared skeleton. Yet both fold into the same pocket of the same enzyme, InhA. That's the enzyme the frontline tuberculosis drug isoniazid was built to shut down. Both of our molecules grip its catalytic residue. Both beat a field of decoys, and a separate structure method agrees. Two strangers, the same target, found by one rule. That's the tool working.</a:t>
+              <a:t>So when Orphan Finder goes past the wall, does it land on real targets? Here's the result that convinced me. Take two molecules. One orphan natural product, and one compound from a drug-repurposing library, made for a different purpose. On that similarity score they sit at zero point two eight, far below the wall. They are chemical strangers, sharing no common skeleton. And yet both fold into the same pocket of the same bacterial enzyme, InhA, the enzyme the frontline tuberculosis drug isoniazid was built to shut down. Both grip the same catalytic residue. Both beat a whole field of decoy controls. And a separate structure-prediction method puts them in the same place. Two chemical strangers, pointed at the same target, found by one rule. That's the tool working.</a:t>
             </a:r>
           </a:p>
         </p:txBody>
@@ -788,7 +788,7 @@
           <a:lstStyle/>
           <a:p>
             <a:r>
-              <a:t>For an antibiotic, naming the target isn't enough. Bacteria fight back. They mutate the target until the drug stops sticking. That's resistance, and it's killing our medicines faster than we replace them. So we taught Orphan Finder a harder question: not just does it bind, but does it still bind after the bacteria mutate? We checked it against resistance we already understand, and it correctly predicted how today's drugs fail. Then we turned it on the orphans. Against the enzyme DHFR, seven natural products are predicted to keep working right where the frontline drug is defeated. Resistance-proof leads, from molecules nobody had a target for.</a:t>
+              <a:t>For an antibiotic, naming the target isn't enough. Bacteria fight back: they mutate the target protein, reshaping the pocket just enough that the drug stops sticking. That's antibiotic resistance, and it's retiring our medicines faster than we invent new ones. So we taught Orphan Finder a harder question, not just does it bind, but does it still bind after the bacteria mutate? We checked it against resistance we already understand, and it correctly reproduced how today's drugs get defeated. Then we turned it on the orphans. Against an enzyme called DHFR, seven orphan natural products are predicted to keep their grip exactly where the frontline drug loses it, holding on through the resistance mutations. Resistance-proof leads, from molecules that had no known target at all.</a:t>
             </a:r>
           </a:p>
         </p:txBody>
@@ -858,7 +858,7 @@
           <a:lstStyle/>
           <a:p>
             <a:r>
-              <a:t>And this isn't just tuberculosis. We pointed the same engine at gut-microbe molecules and asked what they do to us. It flagged a whole family of microbial pigments all hitting one human receptor, PXR, the switch that controls how our bodies clear drugs. Every one confirmed by docking. Antibiotics, the microbiome, the brain. One engine.</a:t>
+              <a:t>And this isn't a one-trick tool for tuberculosis. It's a general instrument, and we proved it on two more problems. First, the microbiome. We aimed the same engine at molecules made by our gut bacteria and asked what they do to us. It flagged a whole family of microbial pigments that all converge on one human protein, PXR, the master switch controlling how our bodies clear drugs. Every one confirmed by docking, a concrete, testable link between our gut microbes and our own drug metabolism. Second, the brain. We ran the same pipeline across 1.7 million brain-penetrant molecules aimed at the two enzymes that Alzheimer's drugs target, AChE and MAO-B. The real Alzheimer's drugs, our controls, scored right where they should, proving the engine transfers cleanly to a whole new disease area at massive scale. Antibiotics, the microbiome, the brain. One engine, three frontiers of human health.</a:t>
             </a:r>
           </a:p>
         </p:txBody>
@@ -928,7 +928,7 @@
           <a:lstStyle/>
           <a:p>
             <a:r>
-              <a:t>Ninety percent of nature's molecules have no known target. That's not a dead end, it's an unopened library. Orphan Finder opens it, and hands you ranked, structure-backed, resistance-aware leads to test. Fully open, fully reproducible. Built on Claude Science. Thank you.</a:t>
+              <a:t>About ninety percent of nature's molecules have no known target. That's not a dead end. It's an enormous, unopened library of possible medicines. Orphan Finder opens it, taking molecules nobody had a target for and handing back ranked, structure-backed, resistance-aware leads a lab can test. It's fully open source, and every result reproduces from the repository. Built on Claude Science. Thank you.</a:t>
             </a:r>
           </a:p>
         </p:txBody>

</xml_diff>

<commit_message>
Slide 6 = microbiome results (why/validation/finding); remove Alzheimer's null from presentation (stays in paper)
</commit_message>
<xml_diff>
--- a/demo/HitScreen_pitch.pptx
+++ b/demo/HitScreen_pitch.pptx
@@ -858,7 +858,7 @@
           <a:lstStyle/>
           <a:p>
             <a:r>
-              <a:t>And this isn't a one-trick tool for tuberculosis. It's a general instrument, and we proved it on two more problems. First, the microbiome. We aimed the same engine at molecules made by our gut bacteria and asked what they do to us. It flagged a whole family of microbial pigments that all converge on one human protein, PXR, the master switch controlling how our bodies clear drugs. Every one confirmed by docking, a concrete, testable link between our gut microbes and our own drug metabolism. Second, the brain. We ran the same pipeline across 1.7 million brain-penetrant molecules aimed at the two enzymes that Alzheimer's drugs target, AChE and MAO-B. The real Alzheimer's drugs, our controls, scored right where they should, proving the engine transfers cleanly to a whole new disease area at massive scale. Antibiotics, the microbiome, the brain. One engine, three frontiers of human health.</a:t>
+              <a:t>And this isn't a one-trick tool for tuberculosis. To prove it generalizes, we pointed the same engine in a new direction: the microbiome. Our gut bacteria constantly release molecules into our bodies, and for most of them we don't know what human proteins they act on. So we asked Orphan Finder. First, a sanity check. Run in this forward direction, the engine re-discovered signaling we already know is real, gut molecules like niacin and secondary bile acids hitting their known human receptors. So the method works here too. Then the new finding. Orphan Finder flagged a whole family of microbial carotenoids, the pigments these bacteria make, all converging on a single human protein: PXR, the master switch that controls how our bodies clear drugs. We docked every one of them, and all nine bind as tightly as rifampicin, the known drug that activates PXR. That's a concrete, testable hypothesis: the pigments in our gut microbes may be tuning how we metabolize medicine. Same engine, a completely different frontier.</a:t>
             </a:r>
           </a:p>
         </p:txBody>
@@ -5205,7 +5205,7 @@
                 </a:solidFill>
                 <a:latin typeface="Arial"/>
               </a:rPr>
-              <a:t>ONE ENGINE, MANY DISEASES</a:t>
+              <a:t>GENERALIZATION | A SECOND APPLICATION</a:t>
             </a:r>
           </a:p>
         </p:txBody>
@@ -5240,7 +5240,7 @@
                 </a:solidFill>
                 <a:latin typeface="Arial"/>
               </a:rPr>
-              <a:t>The same tool, pointed at very different problems</a:t>
+              <a:t>The same engine, pointed at the microbiome</a:t>
             </a:r>
           </a:p>
         </p:txBody>
@@ -5319,7 +5319,7 @@
                 </a:solidFill>
                 <a:latin typeface="Arial"/>
               </a:rPr>
-              <a:t>Antibiotic resistance</a:t>
+              <a:t>Why we looked</a:t>
             </a:r>
           </a:p>
         </p:txBody>
@@ -5354,7 +5354,7 @@
                 </a:solidFill>
                 <a:latin typeface="Arial"/>
               </a:rPr>
-              <a:t>Orphan natural products nominated as resistance-robust leads against priority pathogens.</a:t>
+              <a:t>Gut microbes flood the body with molecules. Which of our own proteins do they act on?</a:t>
             </a:r>
           </a:p>
         </p:txBody>
@@ -5433,7 +5433,7 @@
                 </a:solidFill>
                 <a:latin typeface="Arial"/>
               </a:rPr>
-              <a:t>The microbiome</a:t>
+              <a:t>It recovers known biology</a:t>
             </a:r>
           </a:p>
         </p:txBody>
@@ -5468,7 +5468,7 @@
                 </a:solidFill>
                 <a:latin typeface="Arial"/>
               </a:rPr>
-              <a:t>A family of gut-microbe pigments all converge on PXR, the human receptor that controls how we clear drugs. Confirmed by docking.</a:t>
+              <a:t>The forward screen re-finds established microbe-to-host signaling: niacin to HCAR2, bile acids to FXR and TGR5.</a:t>
             </a:r>
           </a:p>
         </p:txBody>
@@ -5543,11 +5543,11 @@
             <a:r>
               <a:rPr sz="1900" b="1">
                 <a:solidFill>
-                  <a:srgbClr val="58A6FF"/>
+                  <a:srgbClr val="3FB950"/>
                 </a:solidFill>
                 <a:latin typeface="Arial"/>
               </a:rPr>
-              <a:t>The brain: Alzheimer's</a:t>
+              <a:t>The finding</a:t>
             </a:r>
           </a:p>
         </p:txBody>
@@ -5582,7 +5582,7 @@
                 </a:solidFill>
                 <a:latin typeface="Arial"/>
               </a:rPr>
-              <a:t>Same engine run across 1.7M brain-penetrant molecules against the enzymes behind Alzheimer's, AChE and MAO-B. Scales and transfers cleanly.</a:t>
+              <a:t>9 microbial carotenoids converge on PXR, the receptor that controls drug clearance. All dock within 1 kcal/mol of the agonist rifampicin.</a:t>
             </a:r>
           </a:p>
         </p:txBody>

</xml_diff>

<commit_message>
Tighten script: leaner intro (slides 1-2), trimmed slides 5-6; deck notes re-synced
</commit_message>
<xml_diff>
--- a/demo/HitScreen_pitch.pptx
+++ b/demo/HitScreen_pitch.pptx
@@ -508,7 +508,7 @@
           <a:lstStyle/>
           <a:p>
             <a:r>
-              <a:t>I'm James Martin, and this is Orphan Finder. Nature is still our best source of medicine. About half of all approved drugs trace back to a natural product, to something first made by a plant, a microbe, or a fungus. But most of these molecules are stuck. We can see they do something, but we don't know which protein in the body they act on. And without the target, you can't develop the drug. We call those orphan molecules. Orphan Finder gives them a target.</a:t>
+              <a:t>I'm James Martin, and this is Orphan Finder. About half of all approved drugs come from natural products, from plants, microbes, and fungi. But most of these molecules are stuck: we can see they do something, yet we don't know which protein they act on, and without the target you can't build a drug. We call those orphan molecules. Orphan Finder gives them a target.</a:t>
             </a:r>
           </a:p>
         </p:txBody>
@@ -578,7 +578,7 @@
           <a:lstStyle/>
           <a:p>
             <a:r>
-              <a:t>Why don't we already know their targets? It comes down to how prediction normally works. The standard approach is guilt by association: if a new molecule looks like a drug we understand, we assume it hits the same protein. Chemists score that resemblance from zero to one. One means near-identical twins; zero means nothing in common. That works, but only up to a point. The moment a molecule looks like nothing we've seen, there's nothing to compare it to, and the method quietly falls apart. And orphans, by definition, are the molecules that look like nothing we've seen. So we measured where it breaks, and found a hard cliff: below a similarity of one half, prediction stops working. Across 695,000 natural products, sixty-three percent live past that cliff. We call it the analog wall. Our central idea: Orphan Finder always knows which side of that wall it's on. With a close relative, it uses the shortcut. Past the wall, it stops guessing from resemblance and switches to physics, folding the molecule's 3D shape into the protein's pocket to see if it truly fits.</a:t>
+              <a:t>Why don't we already know? It comes down to how prediction normally works: guilt by association. If a new molecule looks like a drug we understand, we assume it hits the same protein. Chemists score that resemblance from zero to one, one means near-identical twins, zero means nothing in common. But that shortcut fails for the molecules that matter most. Orphans, by definition, look like nothing we've seen, so there's nothing to compare them to. We measured exactly where it breaks: below a similarity of one half, prediction collapses. Across 695,000 natural products, sixty-three percent live past that cliff. We call it the analog wall. So here's our idea: Orphan Finder always knows which side of the wall it's on. With a close relative, it uses the shortcut. Past the wall, it switches to physics, folding the molecule's 3D shape into the protein's pocket to see if it truly fits.</a:t>
             </a:r>
           </a:p>
         </p:txBody>
@@ -648,7 +648,7 @@
           <a:lstStyle/>
           <a:p>
             <a:r>
-              <a:t>That whole system runs on Claude Science. From one instruction, it pulls together the world's natural-product libraries, reads in each protein's 3D structure, sends the hard past-the-wall cases to physics-based docking on GPUs, and ranks everything by how strong and how trustworthy the prediction is. You point it at a molecule, and it hands back the proteins it most likely targets, with an honest confidence for each. A months-long lab hunt becomes a single run.</a:t>
+              <a:t>That whole system runs on Claude Science. From one instruction, it pulls together the world's natural-product libraries, reads in each protein's 3D structure, sends the hard past-the-wall cases to physics-based docking on GPUs, and ranks everything by how strong and how trustworthy the prediction is. You point it at a molecule, and it returns the proteins it most likely targets, with an honest confidence for each. A months-long lab hunt becomes a single run.</a:t>
             </a:r>
           </a:p>
         </p:txBody>
@@ -788,7 +788,7 @@
           <a:lstStyle/>
           <a:p>
             <a:r>
-              <a:t>For an antibiotic, naming the target isn't enough. Bacteria fight back: they mutate the target protein, reshaping the pocket just enough that the drug stops sticking. That's antibiotic resistance, and it's retiring our medicines faster than we invent new ones. So we taught Orphan Finder a harder question, not just does it bind, but does it still bind after the bacteria mutate? We checked it against resistance we already understand, and it correctly reproduced how today's drugs get defeated. Then we turned it on the orphans. Against an enzyme called DHFR, seven orphan natural products are predicted to keep their grip exactly where the frontline drug loses it, holding on through the resistance mutations. Resistance-proof leads, from molecules that had no known target at all.</a:t>
+              <a:t>For an antibiotic, naming the target isn't enough. Bacteria fight back, mutating the target until the drug no longer sticks. That's antibiotic resistance, and it's retiring our medicines faster than we invent new ones. So we taught Orphan Finder a harder question: not just does it bind, but does it still bind after the bacteria mutate? We checked it against resistance we already understand, and it correctly reproduced how today's drugs get defeated. Then we turned it on the orphans. Against an enzyme called DHFR, seven orphan natural products are predicted to keep their grip exactly where the frontline drug loses it, holding on through the resistance mutations. Resistance-proof leads, from molecules that had no known target at all.</a:t>
             </a:r>
           </a:p>
         </p:txBody>
@@ -858,7 +858,7 @@
           <a:lstStyle/>
           <a:p>
             <a:r>
-              <a:t>And this isn't a one-trick tool for tuberculosis. To prove it generalizes, we pointed the same engine in a new direction: the microbiome. Our gut bacteria constantly release molecules into our bodies, and for most of them we don't know what human proteins they act on. So we asked Orphan Finder. First, a sanity check. Run in this forward direction, the engine re-discovered signaling we already know is real, gut molecules like niacin and secondary bile acids hitting their known human receptors. So the method works here too. Then the new finding. Orphan Finder flagged a whole family of microbial carotenoids, the pigments these bacteria make, all converging on a single human protein: PXR, the master switch that controls how our bodies clear drugs. We docked every one of them, and all nine bind as tightly as rifampicin, the known drug that activates PXR. That's a concrete, testable hypothesis: the pigments in our gut microbes may be tuning how we metabolize medicine. Same engine, a completely different frontier.</a:t>
+              <a:t>And this isn't a one-trick tool for tuberculosis. To show it generalizes, we pointed the same engine at the microbiome, the molecules our gut bacteria release into us, most of which have no known human target. First a sanity check: the engine re-discovered signaling we already know is real, niacin and bile acids hitting their known human receptors. Then the new finding. It flagged a family of microbial carotenoids, the pigments these bacteria make, all converging on one human protein: PXR, the master switch that controls how our bodies clear drugs. All nine dock as tightly as rifampicin, the known drug that activates it. A concrete, testable hypothesis: our gut microbes' pigments may be tuning how we metabolize medicine. Same engine, a different frontier.</a:t>
             </a:r>
           </a:p>
         </p:txBody>

</xml_diff>

<commit_message>
Second tightening pass: leaner across all slides, results intact; notes re-synced
</commit_message>
<xml_diff>
--- a/demo/HitScreen_pitch.pptx
+++ b/demo/HitScreen_pitch.pptx
@@ -578,7 +578,7 @@
           <a:lstStyle/>
           <a:p>
             <a:r>
-              <a:t>Why don't we already know? It comes down to how prediction normally works: guilt by association. If a new molecule looks like a drug we understand, we assume it hits the same protein. Chemists score that resemblance from zero to one, one means near-identical twins, zero means nothing in common. But that shortcut fails for the molecules that matter most. Orphans, by definition, look like nothing we've seen, so there's nothing to compare them to. We measured exactly where it breaks: below a similarity of one half, prediction collapses. Across 695,000 natural products, sixty-three percent live past that cliff. We call it the analog wall. So here's our idea: Orphan Finder always knows which side of the wall it's on. With a close relative, it uses the shortcut. Past the wall, it switches to physics, folding the molecule's 3D shape into the protein's pocket to see if it truly fits.</a:t>
+              <a:t>Why don't we already know? It comes down to how prediction normally works: guilt by association. If a new molecule looks like a drug we understand, we assume it hits the same protein. Chemists score that resemblance from zero to one, one means near-identical twins, zero means nothing in common. But that shortcut fails for the molecules that matter most. Orphans, by definition, look like nothing we've seen. We measured exactly where it breaks: below a similarity of one half, prediction collapses. Across 695,000 natural products, sixty-three percent live past that cliff. We call it the analog wall. So here's our idea: Orphan Finder always knows which side of the wall it's on. With a close relative, it uses the shortcut. Past the wall, it switches to physics, folding the molecule's 3D shape into the protein's pocket to see if it truly fits.</a:t>
             </a:r>
           </a:p>
         </p:txBody>
@@ -648,7 +648,7 @@
           <a:lstStyle/>
           <a:p>
             <a:r>
-              <a:t>That whole system runs on Claude Science. From one instruction, it pulls together the world's natural-product libraries, reads in each protein's 3D structure, sends the hard past-the-wall cases to physics-based docking on GPUs, and ranks everything by how strong and how trustworthy the prediction is. You point it at a molecule, and it returns the proteins it most likely targets, with an honest confidence for each. A months-long lab hunt becomes a single run.</a:t>
+              <a:t>That whole system runs on Claude Science. From one instruction, it pulls together the world's natural-product libraries, reads each protein's structure, sends the hard past-the-wall cases to physics-based docking on GPUs, and ranks the results. You point it at a molecule, and it returns the proteins it most likely targets, with an honest confidence for each. A months-long lab hunt becomes a single run.</a:t>
             </a:r>
           </a:p>
         </p:txBody>
@@ -718,7 +718,7 @@
           <a:lstStyle/>
           <a:p>
             <a:r>
-              <a:t>So when Orphan Finder goes past the wall, does it land on real targets? Here's the result that convinced me. Take two molecules. One orphan natural product, and one compound from a drug-repurposing library, made for a different purpose. On that similarity score they sit at zero point two eight, far below the wall. They are chemical strangers, sharing no common skeleton. And yet both fold into the same pocket of the same bacterial enzyme, InhA, the enzyme the frontline tuberculosis drug isoniazid was built to shut down. Both grip the same catalytic residue. Both beat a whole field of decoy controls. And a separate structure-prediction method puts them in the same place. Two chemical strangers, pointed at the same target, found by one rule. That's the tool working.</a:t>
+              <a:t>So when Orphan Finder goes past the wall, does it land on real targets? Here's the result that convinced me. Take two molecules. One orphan natural product, and one compound from a drug-repurposing library, made for a different purpose. On that similarity score they sit at zero point two eight, far below the wall. They are chemical strangers, sharing no common skeleton. And yet both fold into the same pocket of the same bacterial enzyme, InhA, the enzyme the tuberculosis drug isoniazid was built to shut down. Both grip the same catalytic residue, both beat a field of decoy controls, and a separate structure method confirms it. Two chemical strangers, pointed at the same target, found by one rule. That's the tool working.</a:t>
             </a:r>
           </a:p>
         </p:txBody>
@@ -858,7 +858,7 @@
           <a:lstStyle/>
           <a:p>
             <a:r>
-              <a:t>And this isn't a one-trick tool for tuberculosis. To show it generalizes, we pointed the same engine at the microbiome, the molecules our gut bacteria release into us, most of which have no known human target. First a sanity check: the engine re-discovered signaling we already know is real, niacin and bile acids hitting their known human receptors. Then the new finding. It flagged a family of microbial carotenoids, the pigments these bacteria make, all converging on one human protein: PXR, the master switch that controls how our bodies clear drugs. All nine dock as tightly as rifampicin, the known drug that activates it. A concrete, testable hypothesis: our gut microbes' pigments may be tuning how we metabolize medicine. Same engine, a different frontier.</a:t>
+              <a:t>And this isn't a one-trick tool for tuberculosis. To show it generalizes, we pointed the same engine at the microbiome, the molecules our gut bacteria release into us, most of which have no known human target. First, a sanity check: it re-discovered signaling we already know, niacin and bile acids hitting their known receptors. Then the new finding. It flagged a family of microbial carotenoids, the pigments these bacteria make, all converging on one human protein: PXR, the master switch controlling how our bodies clear drugs. All nine dock as tightly as rifampicin, the drug that activates it. A concrete, testable hypothesis: our gut microbes' pigments may be tuning how we metabolize medicine. Same engine, a different frontier.</a:t>
             </a:r>
           </a:p>
         </p:txBody>
@@ -928,7 +928,7 @@
           <a:lstStyle/>
           <a:p>
             <a:r>
-              <a:t>About ninety percent of nature's molecules have no known target. That's not a dead end. It's an enormous, unopened library of possible medicines. Orphan Finder opens it, taking molecules nobody had a target for and handing back ranked, structure-backed, resistance-aware leads a lab can test. It's fully open source, and every result reproduces from the repository. Built on Claude Science. Thank you.</a:t>
+              <a:t>About ninety percent of nature's molecules have no known target. That's not a dead end, it's an unopened library of medicines. Orphan Finder opens it, turning molecules nobody had a target for into ranked, structure-backed, resistance-aware leads a lab can test. Fully open source, every result reproducible. Built on Claude Science. Thank you.</a:t>
             </a:r>
           </a:p>
         </p:txBody>

</xml_diff>